<commit_message>
Update report and presentation files
</commit_message>
<xml_diff>
--- a/presentacion/Presentacion_MCP.pptx
+++ b/presentacion/Presentacion_MCP.pptx
@@ -6759,7 +6759,7 @@
               </a:defRPr>
             </a:pPr>
             <a:r>
-              <a:t>Ablación: efecto del mecanismo de reinicio</a:t>
+              <a:t>Experimento de ablación: efecto del mecanismo de reinicio</a:t>
             </a:r>
           </a:p>
         </p:txBody>
@@ -7365,7 +7365,7 @@
               </a:defRPr>
             </a:pPr>
             <a:r>
-              <a:t>Conclusión de la ablación</a:t>
+              <a:t>Conclusión del experimento de ablación</a:t>
             </a:r>
           </a:p>
         </p:txBody>

</xml_diff>